<commit_message>
Release 0.3.0: ten slide layouts and dark slides
Statement, stats, cards, compare, steps, numbered, media, gallery, logos and closing,
picked from the content's shape or named with <!-- layout: name -->. Any slide can be
dark with <!-- tone: dark -->. Colours and sizes come from new theme keys. Markdown
gains blockquotes, and a showcase template uses every layout.
</commit_message>
<xml_diff>
--- a/plugins/imprint/engine/imprint/themes/default/base.pptx
+++ b/plugins/imprint/engine/imprint/themes/default/base.pptx
@@ -788,6 +788,90 @@
 </p:sldLayout>
 </file>
 
+<file path=ppt/slideLayouts/slideLayout8.xml><?xml version="1.0" encoding="utf-8"?>
+<p:sldLayout xmlns:a="http://schemas.openxmlformats.org/drawingml/2006/main" xmlns:r="http://schemas.openxmlformats.org/officeDocument/2006/relationships" xmlns:p="http://schemas.openxmlformats.org/presentationml/2006/main" type="objTx" preserve="1" showMasterSp="0">
+  <p:cSld name="Title Only Dark">
+    <p:bg>
+      <p:bgPr>
+        <a:solidFill>
+          <a:srgbClr val="1A202C"/>
+        </a:solidFill>
+        <a:effectLst/>
+      </p:bgPr>
+    </p:bg>
+    <p:spTree>
+      <p:nvGrpSpPr>
+        <p:cNvPr id="1" name=""/>
+        <p:cNvGrpSpPr/>
+        <p:nvPr/>
+      </p:nvGrpSpPr>
+      <p:grpSpPr>
+        <a:xfrm>
+          <a:off x="0" y="0"/>
+          <a:ext cx="0" cy="0"/>
+          <a:chOff x="0" y="0"/>
+          <a:chExt cx="0" cy="0"/>
+        </a:xfrm>
+      </p:grpSpPr>
+      <p:sp>
+        <p:nvSpPr>
+          <p:cNvPr id="2" name="Title 1"/>
+          <p:cNvSpPr>
+            <a:spLocks noGrp="1"/>
+          </p:cNvSpPr>
+          <p:nvPr>
+            <p:ph type="title"/>
+          </p:nvPr>
+        </p:nvSpPr>
+        <p:spPr>
+          <a:xfrm>
+            <a:off x="548640" y="411480"/>
+            <a:ext cx="11094720" cy="868680"/>
+          </a:xfrm>
+        </p:spPr>
+        <p:txBody>
+          <a:bodyPr anchor="b"/>
+          <a:lstStyle>
+            <a:lvl1pPr marL="0" indent="0" algn="l" defTabSz="914400" rtl="0" eaLnBrk="1" latinLnBrk="0" hangingPunct="1">
+              <a:lnSpc>
+                <a:spcPct val="100000"/>
+              </a:lnSpc>
+              <a:spcBef>
+                <a:spcPts val="0"/>
+              </a:spcBef>
+              <a:buNone/>
+              <a:defRPr sz="2600" b="1" kern="1200">
+                <a:solidFill>
+                  <a:srgbClr val="FFFFFF"/>
+                </a:solidFill>
+                <a:latin typeface="Anuphan SemiBold"/>
+                <a:ea typeface="Anuphan SemiBold"/>
+                <a:cs typeface="Anuphan SemiBold"/>
+              </a:defRPr>
+            </a:lvl1pPr>
+          </a:lstStyle>
+          <a:p>
+            <a:r>
+              <a:rPr lang="en-US" smtClean="0"/>
+              <a:t>Click to edit Master title style</a:t>
+            </a:r>
+            <a:endParaRPr lang="en-US"/>
+          </a:p>
+        </p:txBody>
+      </p:sp>
+    </p:spTree>
+    <p:extLst>
+      <p:ext uri="{BB962C8B-B14F-4D97-AF65-F5344CB8AC3E}">
+        <p14:creationId xmlns:p14="http://schemas.microsoft.com/office/powerpoint/2010/main" val="1840726560"/>
+      </p:ext>
+    </p:extLst>
+  </p:cSld>
+  <p:clrMapOvr>
+    <a:masterClrMapping/>
+  </p:clrMapOvr>
+</p:sldLayout>
+</file>
+
 <file path=ppt/slideMasters/slideMaster1.xml><?xml version="1.0" encoding="utf-8"?>
 <p:sldMaster xmlns:a="http://schemas.openxmlformats.org/drawingml/2006/main" xmlns:r="http://schemas.openxmlformats.org/officeDocument/2006/relationships" xmlns:p="http://schemas.openxmlformats.org/presentationml/2006/main">
   <p:cSld>
@@ -920,6 +1004,7 @@
     <p:sldLayoutId id="2147483652" r:id="rId4"/>
     <p:sldLayoutId id="2147483654" r:id="rId6"/>
     <p:sldLayoutId id="2147483655" r:id="rId7"/>
+    <p:sldLayoutId id="2147483656" r:id="rId8"/>
   </p:sldLayoutIdLst>
   <p:txStyles>
     <p:titleStyle>

</xml_diff>